<commit_message>
Sjöskolan v40: figurerna i presentationerna som bilder ur webbens figurer
PowerPoint-diagrammen och trianglarna av lösa linjer ritades fel i PowerPoint
och Keynote. De ersätts med bilder ur visuals.mjs (verktyg/ac/figurbilder.py).
Figurerna rättade: etiketterna på trianglarna krockade, periodmarkeringen låg
över kurvan och resistorns u och i låg ovanpå varandra. Lärarkopior, PDF och
bildspel byggda om.

Co-Authored-By: Claude Opus 5.5 <noreply@anthropic.com>
Claude-Session: https://claude.ai/code/session_011V9KjBb53XrDm23Dw58SH3
</commit_message>
<xml_diff>
--- a/sjoskolan/vecka-40/aktuell/v40_03_Effekt_i_vaxelstromskretsar_elev.pptx
+++ b/sjoskolan/vecka-40/aktuell/v40_03_Effekt_i_vaxelstromskretsar_elev.pptx
@@ -10593,10 +10593,10 @@
       </p:sp>
       <p:sp>
         <p:nvSpPr>
-          <p:cNvPr id="10" name="real-leg">
-            <a:extLst xmlns:a="http://schemas.openxmlformats.org/drawingml/2006/main">
-              <a:ext uri="{FF2B5EF4-FFF2-40B4-BE49-F238E27FC236}">
-                <a16:creationId xmlns:a16="http://schemas.microsoft.com/office/drawing/2014/main" id="{13AF7545-D9C3-4B57-9E32-A6072F271F30}"/>
+          <p:cNvPr id="18" name="body">
+            <a:extLst xmlns:a="http://schemas.openxmlformats.org/drawingml/2006/main">
+              <a:ext uri="{FF2B5EF4-FFF2-40B4-BE49-F238E27FC236}">
+                <a16:creationId xmlns:a16="http://schemas.microsoft.com/office/drawing/2014/main" id="{B405FD13-70BC-4256-8763-0CBA213AFAAB}"/>
               </a:ext>
             </a:extLst>
           </p:cNvPr>
@@ -10607,223 +10607,8 @@
         </p:nvSpPr>
         <p:spPr>
           <a:xfrm xmlns:a="http://schemas.openxmlformats.org/drawingml/2006/main">
-            <a:off x="3333750" y="3143250"/>
-            <a:ext cx="1044860" cy="9525"/>
-          </a:xfrm>
-          <a:custGeom xmlns:a="http://schemas.openxmlformats.org/drawingml/2006/main">
-            <a:pathLst>
-              <a:path w="1044860" h="9525">
-                <a:moveTo>
-                  <a:pt x="0" y="0"/>
-                </a:moveTo>
-                <a:lnTo>
-                  <a:pt x="1044860" y="0"/>
-                </a:lnTo>
-              </a:path>
-            </a:pathLst>
-          </a:custGeom>
-          <a:noFill xmlns:a="http://schemas.openxmlformats.org/drawingml/2006/main"/>
-          <a:ln xmlns:a="http://schemas.openxmlformats.org/drawingml/2006/main" w="28575">
-            <a:solidFill>
-              <a:srgbClr val="172F43"/>
-            </a:solidFill>
-          </a:ln>
-        </p:spPr>
-        <p:txBody xmlns:a="http://schemas.openxmlformats.org/drawingml/2006/main">
-          <a:bodyPr/>
-          <a:p/>
-        </p:txBody>
-      </p:sp>
-      <p:sp>
-        <p:nvSpPr>
-          <p:cNvPr id="11" name="reactive-leg">
-            <a:extLst xmlns:a="http://schemas.openxmlformats.org/drawingml/2006/main">
-              <a:ext uri="{FF2B5EF4-FFF2-40B4-BE49-F238E27FC236}">
-                <a16:creationId xmlns:a16="http://schemas.microsoft.com/office/drawing/2014/main" id="{168559E0-79AF-47CF-B111-593DB37B01BF}"/>
-              </a:ext>
-            </a:extLst>
-          </p:cNvPr>
-          <p:cNvSpPr>
-            <a:spLocks xmlns:a="http://schemas.openxmlformats.org/drawingml/2006/main" noGrp="1"/>
-          </p:cNvSpPr>
-          <p:nvPr/>
-        </p:nvSpPr>
-        <p:spPr>
-          <a:xfrm xmlns:a="http://schemas.openxmlformats.org/drawingml/2006/main">
-            <a:off x="4378610" y="1333500"/>
-            <a:ext cx="9525" cy="1809750"/>
-          </a:xfrm>
-          <a:custGeom xmlns:a="http://schemas.openxmlformats.org/drawingml/2006/main">
-            <a:pathLst>
-              <a:path w="9525" h="1809750">
-                <a:moveTo>
-                  <a:pt x="0" y="1809750"/>
-                </a:moveTo>
-                <a:lnTo>
-                  <a:pt x="0" y="0"/>
-                </a:lnTo>
-              </a:path>
-            </a:pathLst>
-          </a:custGeom>
-          <a:noFill xmlns:a="http://schemas.openxmlformats.org/drawingml/2006/main"/>
-          <a:ln xmlns:a="http://schemas.openxmlformats.org/drawingml/2006/main" w="28575">
-            <a:solidFill>
-              <a:srgbClr val="AD5018"/>
-            </a:solidFill>
-          </a:ln>
-        </p:spPr>
-        <p:txBody xmlns:a="http://schemas.openxmlformats.org/drawingml/2006/main">
-          <a:bodyPr/>
-          <a:p/>
-        </p:txBody>
-      </p:sp>
-      <p:sp>
-        <p:nvSpPr>
-          <p:cNvPr id="12" name="hypotenuse">
-            <a:extLst xmlns:a="http://schemas.openxmlformats.org/drawingml/2006/main">
-              <a:ext uri="{FF2B5EF4-FFF2-40B4-BE49-F238E27FC236}">
-                <a16:creationId xmlns:a16="http://schemas.microsoft.com/office/drawing/2014/main" id="{EEFD3E55-92C2-404A-9997-9A67DF57A0F2}"/>
-              </a:ext>
-            </a:extLst>
-          </p:cNvPr>
-          <p:cNvSpPr>
-            <a:spLocks xmlns:a="http://schemas.openxmlformats.org/drawingml/2006/main" noGrp="1"/>
-          </p:cNvSpPr>
-          <p:nvPr/>
-        </p:nvSpPr>
-        <p:spPr>
-          <a:xfrm xmlns:a="http://schemas.openxmlformats.org/drawingml/2006/main">
-            <a:off x="3333750" y="1333500"/>
-            <a:ext cx="1044860" cy="1809750"/>
-          </a:xfrm>
-          <a:custGeom xmlns:a="http://schemas.openxmlformats.org/drawingml/2006/main">
-            <a:pathLst>
-              <a:path w="1044860" h="1809750">
-                <a:moveTo>
-                  <a:pt x="0" y="1809750"/>
-                </a:moveTo>
-                <a:lnTo>
-                  <a:pt x="1044860" y="0"/>
-                </a:lnTo>
-              </a:path>
-            </a:pathLst>
-          </a:custGeom>
-          <a:noFill xmlns:a="http://schemas.openxmlformats.org/drawingml/2006/main"/>
-          <a:ln xmlns:a="http://schemas.openxmlformats.org/drawingml/2006/main" w="28575">
-            <a:solidFill>
-              <a:srgbClr val="064F91"/>
-            </a:solidFill>
-          </a:ln>
-        </p:spPr>
-        <p:txBody xmlns:a="http://schemas.openxmlformats.org/drawingml/2006/main">
-          <a:bodyPr/>
-          <a:p/>
-        </p:txBody>
-      </p:sp>
-      <p:sp>
-        <p:nvSpPr>
-          <p:cNvPr id="13" name="right-angle-h">
-            <a:extLst xmlns:a="http://schemas.openxmlformats.org/drawingml/2006/main">
-              <a:ext uri="{FF2B5EF4-FFF2-40B4-BE49-F238E27FC236}">
-                <a16:creationId xmlns:a16="http://schemas.microsoft.com/office/drawing/2014/main" id="{2E82900D-D4CB-4E81-8B5C-292AEEA52910}"/>
-              </a:ext>
-            </a:extLst>
-          </p:cNvPr>
-          <p:cNvSpPr>
-            <a:spLocks xmlns:a="http://schemas.openxmlformats.org/drawingml/2006/main" noGrp="1"/>
-          </p:cNvSpPr>
-          <p:nvPr/>
-        </p:nvSpPr>
-        <p:spPr>
-          <a:xfrm xmlns:a="http://schemas.openxmlformats.org/drawingml/2006/main">
-            <a:off x="4264310" y="3028950"/>
-            <a:ext cx="114300" cy="9525"/>
-          </a:xfrm>
-          <a:custGeom xmlns:a="http://schemas.openxmlformats.org/drawingml/2006/main">
-            <a:pathLst>
-              <a:path w="114300" h="9525">
-                <a:moveTo>
-                  <a:pt x="0" y="0"/>
-                </a:moveTo>
-                <a:lnTo>
-                  <a:pt x="114300" y="0"/>
-                </a:lnTo>
-              </a:path>
-            </a:pathLst>
-          </a:custGeom>
-          <a:noFill xmlns:a="http://schemas.openxmlformats.org/drawingml/2006/main"/>
-          <a:ln xmlns:a="http://schemas.openxmlformats.org/drawingml/2006/main" w="28575">
-            <a:solidFill>
-              <a:srgbClr val="8394A1"/>
-            </a:solidFill>
-          </a:ln>
-        </p:spPr>
-        <p:txBody xmlns:a="http://schemas.openxmlformats.org/drawingml/2006/main">
-          <a:bodyPr/>
-          <a:p/>
-        </p:txBody>
-      </p:sp>
-      <p:sp>
-        <p:nvSpPr>
-          <p:cNvPr id="14" name="right-angle-v">
-            <a:extLst xmlns:a="http://schemas.openxmlformats.org/drawingml/2006/main">
-              <a:ext uri="{FF2B5EF4-FFF2-40B4-BE49-F238E27FC236}">
-                <a16:creationId xmlns:a16="http://schemas.microsoft.com/office/drawing/2014/main" id="{D7736CFB-E585-43E0-80EC-2A4BCBE59078}"/>
-              </a:ext>
-            </a:extLst>
-          </p:cNvPr>
-          <p:cNvSpPr>
-            <a:spLocks xmlns:a="http://schemas.openxmlformats.org/drawingml/2006/main" noGrp="1"/>
-          </p:cNvSpPr>
-          <p:nvPr/>
-        </p:nvSpPr>
-        <p:spPr>
-          <a:xfrm xmlns:a="http://schemas.openxmlformats.org/drawingml/2006/main">
-            <a:off x="4264310" y="3028950"/>
-            <a:ext cx="9525" cy="114300"/>
-          </a:xfrm>
-          <a:custGeom xmlns:a="http://schemas.openxmlformats.org/drawingml/2006/main">
-            <a:pathLst>
-              <a:path w="9525" h="114300">
-                <a:moveTo>
-                  <a:pt x="0" y="0"/>
-                </a:moveTo>
-                <a:lnTo>
-                  <a:pt x="0" y="114300"/>
-                </a:lnTo>
-              </a:path>
-            </a:pathLst>
-          </a:custGeom>
-          <a:noFill xmlns:a="http://schemas.openxmlformats.org/drawingml/2006/main"/>
-          <a:ln xmlns:a="http://schemas.openxmlformats.org/drawingml/2006/main" w="28575">
-            <a:solidFill>
-              <a:srgbClr val="8394A1"/>
-            </a:solidFill>
-          </a:ln>
-        </p:spPr>
-        <p:txBody xmlns:a="http://schemas.openxmlformats.org/drawingml/2006/main">
-          <a:bodyPr/>
-          <a:p/>
-        </p:txBody>
-      </p:sp>
-      <p:sp>
-        <p:nvSpPr>
-          <p:cNvPr id="15" name="horizontal-label">
-            <a:extLst xmlns:a="http://schemas.openxmlformats.org/drawingml/2006/main">
-              <a:ext uri="{FF2B5EF4-FFF2-40B4-BE49-F238E27FC236}">
-                <a16:creationId xmlns:a16="http://schemas.microsoft.com/office/drawing/2014/main" id="{EDC2AEC1-BC53-4C48-AA22-C355F0AF49D1}"/>
-              </a:ext>
-            </a:extLst>
-          </p:cNvPr>
-          <p:cNvSpPr>
-            <a:spLocks xmlns:a="http://schemas.openxmlformats.org/drawingml/2006/main" noGrp="1"/>
-          </p:cNvSpPr>
-          <p:nvPr/>
-        </p:nvSpPr>
-        <p:spPr>
-          <a:xfrm xmlns:a="http://schemas.openxmlformats.org/drawingml/2006/main">
-            <a:off x="3286125" y="3219450"/>
-            <a:ext cx="2667000" cy="285750"/>
+            <a:off x="762000" y="3905250"/>
+            <a:ext cx="7620000" cy="2044750"/>
           </a:xfrm>
           <a:prstGeom xmlns:a="http://schemas.openxmlformats.org/drawingml/2006/main" prst="rect">
             <a:avLst/>
@@ -10840,35 +10625,116 @@
           <a:lstStyle xmlns:a="http://schemas.openxmlformats.org/drawingml/2006/main"/>
           <a:p xmlns:a="http://schemas.openxmlformats.org/drawingml/2006/main">
             <a:pPr>
-              <a:defRPr sz="1650" b="1">
-                <a:solidFill>
-                  <a:srgbClr val="172F43"/>
-                </a:solidFill>
-                <a:latin typeface="Calibri"/>
-                <a:ea typeface="Calibri"/>
-                <a:cs typeface="Calibri"/>
-              </a:defRPr>
-            </a:pPr>
-            <a:r>
-              <a:rPr sz="1650" b="1">
-                <a:solidFill>
-                  <a:srgbClr val="172F43"/>
-                </a:solidFill>
-                <a:latin typeface="Calibri"/>
-                <a:ea typeface="Calibri"/>
-                <a:cs typeface="Calibri"/>
-              </a:rPr>
-              <a:t>P = 1 380 W</a:t>
-            </a:r>
-          </a:p>
-        </p:txBody>
-      </p:sp>
-      <p:sp>
-        <p:nvSpPr>
-          <p:cNvPr id="16" name="vertical-label">
-            <a:extLst xmlns:a="http://schemas.openxmlformats.org/drawingml/2006/main">
-              <a:ext uri="{FF2B5EF4-FFF2-40B4-BE49-F238E27FC236}">
-                <a16:creationId xmlns:a16="http://schemas.microsoft.com/office/drawing/2014/main" id="{57FE82B3-ED82-4055-94CD-168C5B1F74BB}"/>
+              <a:spcAft>
+                <a:spcPts val="800"/>
+              </a:spcAft>
+              <a:defRPr sz="1650" b="0">
+                <a:solidFill>
+                  <a:srgbClr val="172F43"/>
+                </a:solidFill>
+                <a:latin typeface="Calibri"/>
+                <a:ea typeface="Calibri"/>
+                <a:cs typeface="Calibri"/>
+              </a:defRPr>
+            </a:pPr>
+            <a:r>
+              <a:rPr sz="1600" b="0">
+                <a:solidFill>
+                  <a:srgbClr val="172F43"/>
+                </a:solidFill>
+                <a:latin typeface="Calibri"/>
+                <a:ea typeface="Calibri"/>
+                <a:cs typeface="Calibri"/>
+              </a:rPr>
+              <a:t>Reaktiv effekt Q beskriver energi som går fram och tillbaka mellan källan och spolar eller kondensatorer. Den förbrukas inte, men ger ändå ström i ledningarna.</a:t>
+            </a:r>
+          </a:p>
+          <a:p xmlns:a="http://schemas.openxmlformats.org/drawingml/2006/main">
+            <a:pPr>
+              <a:spcAft>
+                <a:spcPts val="800"/>
+              </a:spcAft>
+              <a:defRPr sz="1650" b="0">
+                <a:solidFill>
+                  <a:srgbClr val="172F43"/>
+                </a:solidFill>
+                <a:latin typeface="Calibri"/>
+                <a:ea typeface="Calibri"/>
+                <a:cs typeface="Calibri"/>
+              </a:defRPr>
+            </a:pPr>
+            <a:r>
+              <a:rPr sz="1600" b="0">
+                <a:solidFill>
+                  <a:srgbClr val="172F43"/>
+                </a:solidFill>
+                <a:latin typeface="Calibri"/>
+                <a:ea typeface="Calibri"/>
+                <a:cs typeface="Calibri"/>
+              </a:rPr>
+              <a:t>För sinus: S² = P² + Q². Därför |Q| = √(S² − P²).</a:t>
+            </a:r>
+          </a:p>
+          <a:p xmlns:a="http://schemas.openxmlformats.org/drawingml/2006/main">
+            <a:pPr>
+              <a:spcAft>
+                <a:spcPts val="800"/>
+              </a:spcAft>
+              <a:defRPr sz="1650" b="0">
+                <a:solidFill>
+                  <a:srgbClr val="172F43"/>
+                </a:solidFill>
+                <a:latin typeface="Calibri"/>
+                <a:ea typeface="Calibri"/>
+                <a:cs typeface="Calibri"/>
+              </a:defRPr>
+            </a:pPr>
+            <a:r>
+              <a:rPr sz="1600" b="0">
+                <a:solidFill>
+                  <a:srgbClr val="172F43"/>
+                </a:solidFill>
+                <a:latin typeface="Calibri"/>
+                <a:ea typeface="Calibri"/>
+                <a:cs typeface="Calibri"/>
+              </a:rPr>
+              <a:t>Exempel: S = 2 760 VA och P = 1 380 W ger |Q| ≈ 2 390,23 var. Enheten var betyder voltampere reaktiv.</a:t>
+            </a:r>
+          </a:p>
+          <a:p xmlns:a="http://schemas.openxmlformats.org/drawingml/2006/main">
+            <a:pPr>
+              <a:spcAft>
+                <a:spcPts val="800"/>
+              </a:spcAft>
+              <a:defRPr sz="1650" b="0">
+                <a:solidFill>
+                  <a:srgbClr val="172F43"/>
+                </a:solidFill>
+                <a:latin typeface="Calibri"/>
+                <a:ea typeface="Calibri"/>
+                <a:cs typeface="Calibri"/>
+              </a:defRPr>
+            </a:pPr>
+            <a:r>
+              <a:rPr sz="1600" b="0">
+                <a:solidFill>
+                  <a:srgbClr val="172F43"/>
+                </a:solidFill>
+                <a:latin typeface="Calibri"/>
+                <a:ea typeface="Calibri"/>
+                <a:cs typeface="Calibri"/>
+              </a:rPr>
+              <a:t>I kursens teckenkonvention är induktiv Q positiv och kapacitiv Q negativ.</a:t>
+            </a:r>
+          </a:p>
+        </p:txBody>
+      </p:sp>
+      <p:sp>
+        <p:nvSpPr>
+          <p:cNvPr id="19" name="formula">
+            <a:extLst xmlns:a="http://schemas.openxmlformats.org/drawingml/2006/main">
+              <a:ext uri="{FF2B5EF4-FFF2-40B4-BE49-F238E27FC236}">
+                <a16:creationId xmlns:a16="http://schemas.microsoft.com/office/drawing/2014/main" id="{092E72CF-88D7-4EDD-A111-A6F4949BA795}"/>
               </a:ext>
             </a:extLst>
           </p:cNvPr>
@@ -10879,8 +10745,8 @@
         </p:nvSpPr>
         <p:spPr>
           <a:xfrm xmlns:a="http://schemas.openxmlformats.org/drawingml/2006/main">
-            <a:off x="4569110" y="2143125"/>
-            <a:ext cx="2571750" cy="285750"/>
+            <a:off x="809625" y="3552825"/>
+            <a:ext cx="7524750" cy="304800"/>
           </a:xfrm>
           <a:prstGeom xmlns:a="http://schemas.openxmlformats.org/drawingml/2006/main" prst="rect">
             <a:avLst/>
@@ -10897,35 +10763,35 @@
           <a:lstStyle xmlns:a="http://schemas.openxmlformats.org/drawingml/2006/main"/>
           <a:p xmlns:a="http://schemas.openxmlformats.org/drawingml/2006/main">
             <a:pPr>
-              <a:defRPr sz="1650" b="1">
-                <a:solidFill>
-                  <a:srgbClr val="AD5018"/>
-                </a:solidFill>
-                <a:latin typeface="Calibri"/>
-                <a:ea typeface="Calibri"/>
-                <a:cs typeface="Calibri"/>
-              </a:defRPr>
-            </a:pPr>
-            <a:r>
-              <a:rPr sz="1650" b="1">
-                <a:solidFill>
-                  <a:srgbClr val="AD5018"/>
-                </a:solidFill>
-                <a:latin typeface="Calibri"/>
-                <a:ea typeface="Calibri"/>
-                <a:cs typeface="Calibri"/>
-              </a:rPr>
-              <a:t>Q ≈ 2 390 var</a:t>
-            </a:r>
-          </a:p>
-        </p:txBody>
-      </p:sp>
-      <p:sp>
-        <p:nvSpPr>
-          <p:cNvPr id="17" name="diagonal-label">
-            <a:extLst xmlns:a="http://schemas.openxmlformats.org/drawingml/2006/main">
-              <a:ext uri="{FF2B5EF4-FFF2-40B4-BE49-F238E27FC236}">
-                <a16:creationId xmlns:a16="http://schemas.microsoft.com/office/drawing/2014/main" id="{5BC1B119-DCDD-4C6A-864F-386795572A72}"/>
+              <a:defRPr sz="1725" b="1">
+                <a:solidFill>
+                  <a:srgbClr val="064F91"/>
+                </a:solidFill>
+                <a:latin typeface="Calibri"/>
+                <a:ea typeface="Calibri"/>
+                <a:cs typeface="Calibri"/>
+              </a:defRPr>
+            </a:pPr>
+            <a:r>
+              <a:rPr sz="1725" b="1">
+                <a:solidFill>
+                  <a:srgbClr val="064F91"/>
+                </a:solidFill>
+                <a:latin typeface="Calibri"/>
+                <a:ea typeface="Calibri"/>
+                <a:cs typeface="Calibri"/>
+              </a:rPr>
+              <a:t>|Q| = √(S² − P²)</a:t>
+            </a:r>
+          </a:p>
+        </p:txBody>
+      </p:sp>
+      <p:sp>
+        <p:nvSpPr>
+          <p:cNvPr id="20" name="section">
+            <a:extLst xmlns:a="http://schemas.openxmlformats.org/drawingml/2006/main">
+              <a:ext uri="{FF2B5EF4-FFF2-40B4-BE49-F238E27FC236}">
+                <a16:creationId xmlns:a16="http://schemas.microsoft.com/office/drawing/2014/main" id="{52A2DC57-E85F-4021-81C3-3D7E97672920}"/>
               </a:ext>
             </a:extLst>
           </p:cNvPr>
@@ -10936,8 +10802,8 @@
         </p:nvSpPr>
         <p:spPr>
           <a:xfrm xmlns:a="http://schemas.openxmlformats.org/drawingml/2006/main">
-            <a:off x="1143000" y="1476375"/>
-            <a:ext cx="2190750" cy="285750"/>
+            <a:off x="1809750" y="6419850"/>
+            <a:ext cx="4191000" cy="266700"/>
           </a:xfrm>
           <a:prstGeom xmlns:a="http://schemas.openxmlformats.org/drawingml/2006/main" prst="rect">
             <a:avLst/>
@@ -10954,35 +10820,35 @@
           <a:lstStyle xmlns:a="http://schemas.openxmlformats.org/drawingml/2006/main"/>
           <a:p xmlns:a="http://schemas.openxmlformats.org/drawingml/2006/main">
             <a:pPr>
-              <a:defRPr sz="1800" b="1">
-                <a:solidFill>
-                  <a:srgbClr val="064F91"/>
-                </a:solidFill>
-                <a:latin typeface="Calibri"/>
-                <a:ea typeface="Calibri"/>
-                <a:cs typeface="Calibri"/>
-              </a:defRPr>
-            </a:pPr>
-            <a:r>
-              <a:rPr sz="1800" b="1">
-                <a:solidFill>
-                  <a:srgbClr val="064F91"/>
-                </a:solidFill>
-                <a:latin typeface="Calibri"/>
-                <a:ea typeface="Calibri"/>
-                <a:cs typeface="Calibri"/>
-              </a:rPr>
-              <a:t>S = 2 760 VA</a:t>
-            </a:r>
-          </a:p>
-        </p:txBody>
-      </p:sp>
-      <p:sp>
-        <p:nvSpPr>
-          <p:cNvPr id="18" name="body">
-            <a:extLst xmlns:a="http://schemas.openxmlformats.org/drawingml/2006/main">
-              <a:ext uri="{FF2B5EF4-FFF2-40B4-BE49-F238E27FC236}">
-                <a16:creationId xmlns:a16="http://schemas.microsoft.com/office/drawing/2014/main" id="{B405FD13-70BC-4256-8763-0CBA213AFAAB}"/>
+              <a:defRPr sz="1275" b="0">
+                <a:solidFill>
+                  <a:srgbClr val="FFFFFF"/>
+                </a:solidFill>
+                <a:latin typeface="Calibri"/>
+                <a:ea typeface="Calibri"/>
+                <a:cs typeface="Calibri"/>
+              </a:defRPr>
+            </a:pPr>
+            <a:r>
+              <a:rPr sz="1275" b="0">
+                <a:solidFill>
+                  <a:srgbClr val="FFFFFF"/>
+                </a:solidFill>
+                <a:latin typeface="Calibri"/>
+                <a:ea typeface="Calibri"/>
+                <a:cs typeface="Calibri"/>
+              </a:rPr>
+              <a:t>Grunddel</a:t>
+            </a:r>
+          </a:p>
+        </p:txBody>
+      </p:sp>
+      <p:sp>
+        <p:nvSpPr>
+          <p:cNvPr id="21" name="page">
+            <a:extLst xmlns:a="http://schemas.openxmlformats.org/drawingml/2006/main">
+              <a:ext uri="{FF2B5EF4-FFF2-40B4-BE49-F238E27FC236}">
+                <a16:creationId xmlns:a16="http://schemas.microsoft.com/office/drawing/2014/main" id="{703FF835-9398-4A00-A11B-295FB1135E66}"/>
               </a:ext>
             </a:extLst>
           </p:cNvPr>
@@ -10993,8 +10859,8 @@
         </p:nvSpPr>
         <p:spPr>
           <a:xfrm xmlns:a="http://schemas.openxmlformats.org/drawingml/2006/main">
-            <a:off x="762000" y="3905250"/>
-            <a:ext cx="7620000" cy="2044750"/>
+            <a:off x="8286750" y="6438900"/>
+            <a:ext cx="428625" cy="285750"/>
           </a:xfrm>
           <a:prstGeom xmlns:a="http://schemas.openxmlformats.org/drawingml/2006/main" prst="rect">
             <a:avLst/>
@@ -11011,281 +10877,53 @@
           <a:lstStyle xmlns:a="http://schemas.openxmlformats.org/drawingml/2006/main"/>
           <a:p xmlns:a="http://schemas.openxmlformats.org/drawingml/2006/main">
             <a:pPr>
-              <a:spcAft>
-                <a:spcPts val="800"/>
-              </a:spcAft>
-              <a:defRPr sz="1650" b="0">
-                <a:solidFill>
-                  <a:srgbClr val="172F43"/>
-                </a:solidFill>
-                <a:latin typeface="Calibri"/>
-                <a:ea typeface="Calibri"/>
-                <a:cs typeface="Calibri"/>
-              </a:defRPr>
-            </a:pPr>
-            <a:r>
-              <a:rPr sz="1600" b="0">
-                <a:solidFill>
-                  <a:srgbClr val="172F43"/>
-                </a:solidFill>
-                <a:latin typeface="Calibri"/>
-                <a:ea typeface="Calibri"/>
-                <a:cs typeface="Calibri"/>
-              </a:rPr>
-              <a:t>Reaktiv effekt Q beskriver energi som går fram och tillbaka mellan källan och spolar eller kondensatorer. Den förbrukas inte, men ger ändå ström i ledningarna.</a:t>
-            </a:r>
-          </a:p>
-          <a:p xmlns:a="http://schemas.openxmlformats.org/drawingml/2006/main">
-            <a:pPr>
-              <a:spcAft>
-                <a:spcPts val="800"/>
-              </a:spcAft>
-              <a:defRPr sz="1650" b="0">
-                <a:solidFill>
-                  <a:srgbClr val="172F43"/>
-                </a:solidFill>
-                <a:latin typeface="Calibri"/>
-                <a:ea typeface="Calibri"/>
-                <a:cs typeface="Calibri"/>
-              </a:defRPr>
-            </a:pPr>
-            <a:r>
-              <a:rPr sz="1600" b="0">
-                <a:solidFill>
-                  <a:srgbClr val="172F43"/>
-                </a:solidFill>
-                <a:latin typeface="Calibri"/>
-                <a:ea typeface="Calibri"/>
-                <a:cs typeface="Calibri"/>
-              </a:rPr>
-              <a:t>För sinus: S² = P² + Q². Därför |Q| = √(S² − P²).</a:t>
-            </a:r>
-          </a:p>
-          <a:p xmlns:a="http://schemas.openxmlformats.org/drawingml/2006/main">
-            <a:pPr>
-              <a:spcAft>
-                <a:spcPts val="800"/>
-              </a:spcAft>
-              <a:defRPr sz="1650" b="0">
-                <a:solidFill>
-                  <a:srgbClr val="172F43"/>
-                </a:solidFill>
-                <a:latin typeface="Calibri"/>
-                <a:ea typeface="Calibri"/>
-                <a:cs typeface="Calibri"/>
-              </a:defRPr>
-            </a:pPr>
-            <a:r>
-              <a:rPr sz="1600" b="0">
-                <a:solidFill>
-                  <a:srgbClr val="172F43"/>
-                </a:solidFill>
-                <a:latin typeface="Calibri"/>
-                <a:ea typeface="Calibri"/>
-                <a:cs typeface="Calibri"/>
-              </a:rPr>
-              <a:t>Exempel: S = 2 760 VA och P = 1 380 W ger |Q| ≈ 2 390,23 var. Enheten var betyder voltampere reaktiv.</a:t>
-            </a:r>
-          </a:p>
-          <a:p xmlns:a="http://schemas.openxmlformats.org/drawingml/2006/main">
-            <a:pPr>
-              <a:spcAft>
-                <a:spcPts val="800"/>
-              </a:spcAft>
-              <a:defRPr sz="1650" b="0">
-                <a:solidFill>
-                  <a:srgbClr val="172F43"/>
-                </a:solidFill>
-                <a:latin typeface="Calibri"/>
-                <a:ea typeface="Calibri"/>
-                <a:cs typeface="Calibri"/>
-              </a:defRPr>
-            </a:pPr>
-            <a:r>
-              <a:rPr sz="1600" b="0">
-                <a:solidFill>
-                  <a:srgbClr val="172F43"/>
-                </a:solidFill>
-                <a:latin typeface="Calibri"/>
-                <a:ea typeface="Calibri"/>
-                <a:cs typeface="Calibri"/>
-              </a:rPr>
-              <a:t>I kursens teckenkonvention är induktiv Q positiv och kapacitiv Q negativ.</a:t>
-            </a:r>
-          </a:p>
-        </p:txBody>
-      </p:sp>
-      <p:sp>
-        <p:nvSpPr>
-          <p:cNvPr id="19" name="formula">
-            <a:extLst xmlns:a="http://schemas.openxmlformats.org/drawingml/2006/main">
-              <a:ext uri="{FF2B5EF4-FFF2-40B4-BE49-F238E27FC236}">
-                <a16:creationId xmlns:a16="http://schemas.microsoft.com/office/drawing/2014/main" id="{092E72CF-88D7-4EDD-A111-A6F4949BA795}"/>
-              </a:ext>
-            </a:extLst>
-          </p:cNvPr>
-          <p:cNvSpPr>
-            <a:spLocks xmlns:a="http://schemas.openxmlformats.org/drawingml/2006/main" noGrp="1"/>
-          </p:cNvSpPr>
+              <a:defRPr sz="1500" b="0">
+                <a:solidFill>
+                  <a:srgbClr val="FFFFFF"/>
+                </a:solidFill>
+                <a:latin typeface="Calibri"/>
+                <a:ea typeface="Calibri"/>
+                <a:cs typeface="Calibri"/>
+              </a:defRPr>
+            </a:pPr>
+            <a:r>
+              <a:rPr sz="1500" b="0">
+                <a:solidFill>
+                  <a:srgbClr val="FFFFFF"/>
+                </a:solidFill>
+                <a:latin typeface="Calibri"/>
+                <a:ea typeface="Calibri"/>
+                <a:cs typeface="Calibri"/>
+              </a:rPr>
+              <a:t>7</a:t>
+            </a:r>
+          </a:p>
+        </p:txBody>
+      </p:sp>
+      <p:pic xmlns:a="http://schemas.openxmlformats.org/drawingml/2006/main" xmlns:r="http://schemas.openxmlformats.org/officeDocument/2006/relationships">
+        <p:nvPicPr>
+          <p:cNvPr id="23" name="figur-kurva-powerTriangle" descr="Reaktiv effekt"/>
+          <p:cNvPicPr>
+            <a:picLocks noChangeAspect="1"/>
+          </p:cNvPicPr>
           <p:nvPr/>
-        </p:nvSpPr>
-        <p:spPr>
-          <a:xfrm xmlns:a="http://schemas.openxmlformats.org/drawingml/2006/main">
-            <a:off x="809625" y="3552825"/>
-            <a:ext cx="7524750" cy="304800"/>
-          </a:xfrm>
-          <a:prstGeom xmlns:a="http://schemas.openxmlformats.org/drawingml/2006/main" prst="rect">
+        </p:nvPicPr>
+        <p:blipFill>
+          <a:blip r:embed="rId5"/>
+          <a:stretch>
+            <a:fillRect/>
+          </a:stretch>
+        </p:blipFill>
+        <p:spPr>
+          <a:xfrm>
+            <a:off x="859536" y="1188720"/>
+            <a:ext cx="7424927" cy="2386583"/>
+          </a:xfrm>
+          <a:prstGeom prst="rect">
             <a:avLst/>
           </a:prstGeom>
-          <a:noFill xmlns:a="http://schemas.openxmlformats.org/drawingml/2006/main"/>
-          <a:ln xmlns:a="http://schemas.openxmlformats.org/drawingml/2006/main" w="0">
-            <a:noFill/>
-          </a:ln>
-        </p:spPr>
-        <p:txBody>
-          <a:bodyPr xmlns:a="http://schemas.openxmlformats.org/drawingml/2006/main" lIns="0" tIns="0" rIns="0" bIns="0" anchor="t">
-            <a:noAutofit/>
-          </a:bodyPr>
-          <a:lstStyle xmlns:a="http://schemas.openxmlformats.org/drawingml/2006/main"/>
-          <a:p xmlns:a="http://schemas.openxmlformats.org/drawingml/2006/main">
-            <a:pPr>
-              <a:defRPr sz="1725" b="1">
-                <a:solidFill>
-                  <a:srgbClr val="064F91"/>
-                </a:solidFill>
-                <a:latin typeface="Calibri"/>
-                <a:ea typeface="Calibri"/>
-                <a:cs typeface="Calibri"/>
-              </a:defRPr>
-            </a:pPr>
-            <a:r>
-              <a:rPr sz="1725" b="1">
-                <a:solidFill>
-                  <a:srgbClr val="064F91"/>
-                </a:solidFill>
-                <a:latin typeface="Calibri"/>
-                <a:ea typeface="Calibri"/>
-                <a:cs typeface="Calibri"/>
-              </a:rPr>
-              <a:t>|Q| = √(S² − P²)</a:t>
-            </a:r>
-          </a:p>
-        </p:txBody>
-      </p:sp>
-      <p:sp>
-        <p:nvSpPr>
-          <p:cNvPr id="20" name="section">
-            <a:extLst xmlns:a="http://schemas.openxmlformats.org/drawingml/2006/main">
-              <a:ext uri="{FF2B5EF4-FFF2-40B4-BE49-F238E27FC236}">
-                <a16:creationId xmlns:a16="http://schemas.microsoft.com/office/drawing/2014/main" id="{52A2DC57-E85F-4021-81C3-3D7E97672920}"/>
-              </a:ext>
-            </a:extLst>
-          </p:cNvPr>
-          <p:cNvSpPr>
-            <a:spLocks xmlns:a="http://schemas.openxmlformats.org/drawingml/2006/main" noGrp="1"/>
-          </p:cNvSpPr>
-          <p:nvPr/>
-        </p:nvSpPr>
-        <p:spPr>
-          <a:xfrm xmlns:a="http://schemas.openxmlformats.org/drawingml/2006/main">
-            <a:off x="1809750" y="6419850"/>
-            <a:ext cx="4191000" cy="266700"/>
-          </a:xfrm>
-          <a:prstGeom xmlns:a="http://schemas.openxmlformats.org/drawingml/2006/main" prst="rect">
-            <a:avLst/>
-          </a:prstGeom>
-          <a:noFill xmlns:a="http://schemas.openxmlformats.org/drawingml/2006/main"/>
-          <a:ln xmlns:a="http://schemas.openxmlformats.org/drawingml/2006/main" w="0">
-            <a:noFill/>
-          </a:ln>
-        </p:spPr>
-        <p:txBody>
-          <a:bodyPr xmlns:a="http://schemas.openxmlformats.org/drawingml/2006/main" lIns="0" tIns="0" rIns="0" bIns="0" anchor="t">
-            <a:noAutofit/>
-          </a:bodyPr>
-          <a:lstStyle xmlns:a="http://schemas.openxmlformats.org/drawingml/2006/main"/>
-          <a:p xmlns:a="http://schemas.openxmlformats.org/drawingml/2006/main">
-            <a:pPr>
-              <a:defRPr sz="1275" b="0">
-                <a:solidFill>
-                  <a:srgbClr val="FFFFFF"/>
-                </a:solidFill>
-                <a:latin typeface="Calibri"/>
-                <a:ea typeface="Calibri"/>
-                <a:cs typeface="Calibri"/>
-              </a:defRPr>
-            </a:pPr>
-            <a:r>
-              <a:rPr sz="1275" b="0">
-                <a:solidFill>
-                  <a:srgbClr val="FFFFFF"/>
-                </a:solidFill>
-                <a:latin typeface="Calibri"/>
-                <a:ea typeface="Calibri"/>
-                <a:cs typeface="Calibri"/>
-              </a:rPr>
-              <a:t>Grunddel</a:t>
-            </a:r>
-          </a:p>
-        </p:txBody>
-      </p:sp>
-      <p:sp>
-        <p:nvSpPr>
-          <p:cNvPr id="21" name="page">
-            <a:extLst xmlns:a="http://schemas.openxmlformats.org/drawingml/2006/main">
-              <a:ext uri="{FF2B5EF4-FFF2-40B4-BE49-F238E27FC236}">
-                <a16:creationId xmlns:a16="http://schemas.microsoft.com/office/drawing/2014/main" id="{703FF835-9398-4A00-A11B-295FB1135E66}"/>
-              </a:ext>
-            </a:extLst>
-          </p:cNvPr>
-          <p:cNvSpPr>
-            <a:spLocks xmlns:a="http://schemas.openxmlformats.org/drawingml/2006/main" noGrp="1"/>
-          </p:cNvSpPr>
-          <p:nvPr/>
-        </p:nvSpPr>
-        <p:spPr>
-          <a:xfrm xmlns:a="http://schemas.openxmlformats.org/drawingml/2006/main">
-            <a:off x="8286750" y="6438900"/>
-            <a:ext cx="428625" cy="285750"/>
-          </a:xfrm>
-          <a:prstGeom xmlns:a="http://schemas.openxmlformats.org/drawingml/2006/main" prst="rect">
-            <a:avLst/>
-          </a:prstGeom>
-          <a:noFill xmlns:a="http://schemas.openxmlformats.org/drawingml/2006/main"/>
-          <a:ln xmlns:a="http://schemas.openxmlformats.org/drawingml/2006/main" w="0">
-            <a:noFill/>
-          </a:ln>
-        </p:spPr>
-        <p:txBody>
-          <a:bodyPr xmlns:a="http://schemas.openxmlformats.org/drawingml/2006/main" lIns="0" tIns="0" rIns="0" bIns="0" anchor="t">
-            <a:noAutofit/>
-          </a:bodyPr>
-          <a:lstStyle xmlns:a="http://schemas.openxmlformats.org/drawingml/2006/main"/>
-          <a:p xmlns:a="http://schemas.openxmlformats.org/drawingml/2006/main">
-            <a:pPr>
-              <a:defRPr sz="1500" b="0">
-                <a:solidFill>
-                  <a:srgbClr val="FFFFFF"/>
-                </a:solidFill>
-                <a:latin typeface="Calibri"/>
-                <a:ea typeface="Calibri"/>
-                <a:cs typeface="Calibri"/>
-              </a:defRPr>
-            </a:pPr>
-            <a:r>
-              <a:rPr sz="1500" b="0">
-                <a:solidFill>
-                  <a:srgbClr val="FFFFFF"/>
-                </a:solidFill>
-                <a:latin typeface="Calibri"/>
-                <a:ea typeface="Calibri"/>
-                <a:cs typeface="Calibri"/>
-              </a:rPr>
-              <a:t>7</a:t>
-            </a:r>
-          </a:p>
-        </p:txBody>
-      </p:sp>
+        </p:spPr>
+      </p:pic>
     </p:spTree>
     <p:extLst>
       <p:ext uri="{BB962C8B-B14F-4D97-AF65-F5344CB8AC3E}">

</xml_diff>